<commit_message>
Add editable high school placeholder column to 2023 middle-1 class table slide
Co-Authored-By: Claude Opus 5.5 <noreply@anthropic.com>
Claude-Session: https://claude.ai/code/session_015bh4sYU41PMoBKwVo8YRab
</commit_message>
<xml_diff>
--- a/output/isabel-cohorts/2023중1반_총점_성장.pptx
+++ b/output/isabel-cohorts/2023중1반_총점_성장.pptx
@@ -108,7 +108,7 @@
   <p:extLst>
     <p:ext uri="{521415D9-36F7-43E2-AB2F-B90AF26B5E84}">
       <p14:sectionLst xmlns:p14="http://schemas.microsoft.com/office/powerpoint/2010/main">
-        <p14:section name="2023 중1 반" id="{f015b2ca-ae58-9591-cffd-5af85b7886f4}">
+        <p14:section name="2023 중1 반" id="{dd2fcb0b-1428-8910-1060-f92fc23b905a}">
           <p14:sldIdLst>
             <p14:sldId id="256"/>
             <p14:sldId id="257"/>
@@ -1981,12 +1981,13 @@
             <a:tbl>
               <a:tblPr/>
               <a:tblGrid>
+                <a:gridCol w="1371600"/>
+                <a:gridCol w="1463040"/>
+                <a:gridCol w="1645920"/>
+                <a:gridCol w="1645920"/>
+                <a:gridCol w="1645920"/>
+                <a:gridCol w="1554480"/>
                 <a:gridCol w="1737360"/>
-                <a:gridCol w="1737360"/>
-                <a:gridCol w="1920240"/>
-                <a:gridCol w="1920240"/>
-                <a:gridCol w="1920240"/>
-                <a:gridCol w="1828800"/>
               </a:tblGrid>
               <a:tr h="685800">
                 <a:tc>
@@ -2411,6 +2412,67 @@
                     </a:solidFill>
                   </a:tcPr>
                 </a:tc>
+                <a:tc>
+                  <a:txBody>
+                    <a:bodyPr/>
+                    <a:lstStyle/>
+                    <a:p>
+                      <a:pPr algn="ctr" indent="0" marL="0">
+                        <a:buNone/>
+                      </a:pPr>
+                      <a:r>
+                        <a:rPr lang="en-US" sz="1600" b="1" dirty="0">
+                          <a:solidFill>
+                            <a:schemeClr val="bg1"/>
+                          </a:solidFill>
+                        </a:rPr>
+                        <a:t>진학 고등학교</a:t>
+                      </a:r>
+                      <a:endParaRPr lang="en-US" sz="1600" dirty="0"/>
+                    </a:p>
+                  </a:txBody>
+                  <a:tcPr marL="91440" marR="91440" marT="45720" marB="45720" anchor="ctr">
+                    <a:lnL w="9525" cap="flat" cmpd="sng" algn="ctr">
+                      <a:solidFill>
+                        <a:srgbClr val="C9D6D2"/>
+                      </a:solidFill>
+                      <a:prstDash val="solid"/>
+                      <a:round/>
+                      <a:headEnd type="none" w="med" len="med"/>
+                      <a:tailEnd type="none" w="med" len="med"/>
+                    </a:lnL>
+                    <a:lnR w="9525" cap="flat" cmpd="sng" algn="ctr">
+                      <a:solidFill>
+                        <a:srgbClr val="C9D6D2"/>
+                      </a:solidFill>
+                      <a:prstDash val="solid"/>
+                      <a:round/>
+                      <a:headEnd type="none" w="med" len="med"/>
+                      <a:tailEnd type="none" w="med" len="med"/>
+                    </a:lnR>
+                    <a:lnT w="9525" cap="flat" cmpd="sng" algn="ctr">
+                      <a:solidFill>
+                        <a:srgbClr val="C9D6D2"/>
+                      </a:solidFill>
+                      <a:prstDash val="solid"/>
+                      <a:round/>
+                      <a:headEnd type="none" w="med" len="med"/>
+                      <a:tailEnd type="none" w="med" len="med"/>
+                    </a:lnT>
+                    <a:lnB w="9525" cap="flat" cmpd="sng" algn="ctr">
+                      <a:solidFill>
+                        <a:srgbClr val="C9D6D2"/>
+                      </a:solidFill>
+                      <a:prstDash val="solid"/>
+                      <a:round/>
+                      <a:headEnd type="none" w="med" len="med"/>
+                      <a:tailEnd type="none" w="med" len="med"/>
+                    </a:lnB>
+                    <a:solidFill>
+                      <a:schemeClr val="tx2"/>
+                    </a:solidFill>
+                  </a:tcPr>
+                </a:tc>
               </a:tr>
               <a:tr h="548640">
                 <a:tc>
@@ -2733,6 +2795,67 @@
                           </a:solidFill>
                         </a:rPr>
                         <a:t>+29.0</a:t>
+                      </a:r>
+                      <a:endParaRPr lang="en-US" sz="1600" dirty="0"/>
+                    </a:p>
+                  </a:txBody>
+                  <a:tcPr marL="91440" marR="91440" marT="45720" marB="45720" anchor="ctr">
+                    <a:lnL w="9525" cap="flat" cmpd="sng" algn="ctr">
+                      <a:solidFill>
+                        <a:srgbClr val="C9D6D2"/>
+                      </a:solidFill>
+                      <a:prstDash val="solid"/>
+                      <a:round/>
+                      <a:headEnd type="none" w="med" len="med"/>
+                      <a:tailEnd type="none" w="med" len="med"/>
+                    </a:lnL>
+                    <a:lnR w="9525" cap="flat" cmpd="sng" algn="ctr">
+                      <a:solidFill>
+                        <a:srgbClr val="C9D6D2"/>
+                      </a:solidFill>
+                      <a:prstDash val="solid"/>
+                      <a:round/>
+                      <a:headEnd type="none" w="med" len="med"/>
+                      <a:tailEnd type="none" w="med" len="med"/>
+                    </a:lnR>
+                    <a:lnT w="9525" cap="flat" cmpd="sng" algn="ctr">
+                      <a:solidFill>
+                        <a:srgbClr val="C9D6D2"/>
+                      </a:solidFill>
+                      <a:prstDash val="solid"/>
+                      <a:round/>
+                      <a:headEnd type="none" w="med" len="med"/>
+                      <a:tailEnd type="none" w="med" len="med"/>
+                    </a:lnT>
+                    <a:lnB w="9525" cap="flat" cmpd="sng" algn="ctr">
+                      <a:solidFill>
+                        <a:srgbClr val="C9D6D2"/>
+                      </a:solidFill>
+                      <a:prstDash val="solid"/>
+                      <a:round/>
+                      <a:headEnd type="none" w="med" len="med"/>
+                      <a:tailEnd type="none" w="med" len="med"/>
+                    </a:lnB>
+                    <a:solidFill>
+                      <a:schemeClr val="bg1"/>
+                    </a:solidFill>
+                  </a:tcPr>
+                </a:tc>
+                <a:tc>
+                  <a:txBody>
+                    <a:bodyPr/>
+                    <a:lstStyle/>
+                    <a:p>
+                      <a:pPr algn="ctr" indent="0" marL="0">
+                        <a:buNone/>
+                      </a:pPr>
+                      <a:r>
+                        <a:rPr lang="en-US" sz="1600" dirty="0">
+                          <a:solidFill>
+                            <a:schemeClr val="tx1"/>
+                          </a:solidFill>
+                        </a:rPr>
+                        <a:t>A 고등학교</a:t>
                       </a:r>
                       <a:endParaRPr lang="en-US" sz="1600" dirty="0"/>
                     </a:p>
@@ -3147,6 +3270,67 @@
                     </a:solidFill>
                   </a:tcPr>
                 </a:tc>
+                <a:tc>
+                  <a:txBody>
+                    <a:bodyPr/>
+                    <a:lstStyle/>
+                    <a:p>
+                      <a:pPr algn="ctr" indent="0" marL="0">
+                        <a:buNone/>
+                      </a:pPr>
+                      <a:r>
+                        <a:rPr lang="en-US" sz="1600" dirty="0">
+                          <a:solidFill>
+                            <a:schemeClr val="tx1"/>
+                          </a:solidFill>
+                        </a:rPr>
+                        <a:t>B 고등학교</a:t>
+                      </a:r>
+                      <a:endParaRPr lang="en-US" sz="1600" dirty="0"/>
+                    </a:p>
+                  </a:txBody>
+                  <a:tcPr marL="91440" marR="91440" marT="45720" marB="45720" anchor="ctr">
+                    <a:lnL w="9525" cap="flat" cmpd="sng" algn="ctr">
+                      <a:solidFill>
+                        <a:srgbClr val="C9D6D2"/>
+                      </a:solidFill>
+                      <a:prstDash val="solid"/>
+                      <a:round/>
+                      <a:headEnd type="none" w="med" len="med"/>
+                      <a:tailEnd type="none" w="med" len="med"/>
+                    </a:lnL>
+                    <a:lnR w="9525" cap="flat" cmpd="sng" algn="ctr">
+                      <a:solidFill>
+                        <a:srgbClr val="C9D6D2"/>
+                      </a:solidFill>
+                      <a:prstDash val="solid"/>
+                      <a:round/>
+                      <a:headEnd type="none" w="med" len="med"/>
+                      <a:tailEnd type="none" w="med" len="med"/>
+                    </a:lnR>
+                    <a:lnT w="9525" cap="flat" cmpd="sng" algn="ctr">
+                      <a:solidFill>
+                        <a:srgbClr val="C9D6D2"/>
+                      </a:solidFill>
+                      <a:prstDash val="solid"/>
+                      <a:round/>
+                      <a:headEnd type="none" w="med" len="med"/>
+                      <a:tailEnd type="none" w="med" len="med"/>
+                    </a:lnT>
+                    <a:lnB w="9525" cap="flat" cmpd="sng" algn="ctr">
+                      <a:solidFill>
+                        <a:srgbClr val="C9D6D2"/>
+                      </a:solidFill>
+                      <a:prstDash val="solid"/>
+                      <a:round/>
+                      <a:headEnd type="none" w="med" len="med"/>
+                      <a:tailEnd type="none" w="med" len="med"/>
+                    </a:lnB>
+                    <a:solidFill>
+                      <a:schemeClr val="bg1"/>
+                    </a:solidFill>
+                  </a:tcPr>
+                </a:tc>
               </a:tr>
               <a:tr h="548640">
                 <a:tc>
@@ -3469,6 +3653,67 @@
                           </a:solidFill>
                         </a:rPr>
                         <a:t>+17.0</a:t>
+                      </a:r>
+                      <a:endParaRPr lang="en-US" sz="1600" dirty="0"/>
+                    </a:p>
+                  </a:txBody>
+                  <a:tcPr marL="91440" marR="91440" marT="45720" marB="45720" anchor="ctr">
+                    <a:lnL w="9525" cap="flat" cmpd="sng" algn="ctr">
+                      <a:solidFill>
+                        <a:srgbClr val="C9D6D2"/>
+                      </a:solidFill>
+                      <a:prstDash val="solid"/>
+                      <a:round/>
+                      <a:headEnd type="none" w="med" len="med"/>
+                      <a:tailEnd type="none" w="med" len="med"/>
+                    </a:lnL>
+                    <a:lnR w="9525" cap="flat" cmpd="sng" algn="ctr">
+                      <a:solidFill>
+                        <a:srgbClr val="C9D6D2"/>
+                      </a:solidFill>
+                      <a:prstDash val="solid"/>
+                      <a:round/>
+                      <a:headEnd type="none" w="med" len="med"/>
+                      <a:tailEnd type="none" w="med" len="med"/>
+                    </a:lnR>
+                    <a:lnT w="9525" cap="flat" cmpd="sng" algn="ctr">
+                      <a:solidFill>
+                        <a:srgbClr val="C9D6D2"/>
+                      </a:solidFill>
+                      <a:prstDash val="solid"/>
+                      <a:round/>
+                      <a:headEnd type="none" w="med" len="med"/>
+                      <a:tailEnd type="none" w="med" len="med"/>
+                    </a:lnT>
+                    <a:lnB w="9525" cap="flat" cmpd="sng" algn="ctr">
+                      <a:solidFill>
+                        <a:srgbClr val="C9D6D2"/>
+                      </a:solidFill>
+                      <a:prstDash val="solid"/>
+                      <a:round/>
+                      <a:headEnd type="none" w="med" len="med"/>
+                      <a:tailEnd type="none" w="med" len="med"/>
+                    </a:lnB>
+                    <a:solidFill>
+                      <a:schemeClr val="bg1"/>
+                    </a:solidFill>
+                  </a:tcPr>
+                </a:tc>
+                <a:tc>
+                  <a:txBody>
+                    <a:bodyPr/>
+                    <a:lstStyle/>
+                    <a:p>
+                      <a:pPr algn="ctr" indent="0" marL="0">
+                        <a:buNone/>
+                      </a:pPr>
+                      <a:r>
+                        <a:rPr lang="en-US" sz="1600" dirty="0">
+                          <a:solidFill>
+                            <a:schemeClr val="tx1"/>
+                          </a:solidFill>
+                        </a:rPr>
+                        <a:t>C 고등학교</a:t>
                       </a:r>
                       <a:endParaRPr lang="en-US" sz="1600" dirty="0"/>
                     </a:p>
@@ -3883,6 +4128,67 @@
                     </a:solidFill>
                   </a:tcPr>
                 </a:tc>
+                <a:tc>
+                  <a:txBody>
+                    <a:bodyPr/>
+                    <a:lstStyle/>
+                    <a:p>
+                      <a:pPr algn="ctr" indent="0" marL="0">
+                        <a:buNone/>
+                      </a:pPr>
+                      <a:r>
+                        <a:rPr lang="en-US" sz="1600" dirty="0">
+                          <a:solidFill>
+                            <a:schemeClr val="tx1"/>
+                          </a:solidFill>
+                        </a:rPr>
+                        <a:t>D 고등학교</a:t>
+                      </a:r>
+                      <a:endParaRPr lang="en-US" sz="1600" dirty="0"/>
+                    </a:p>
+                  </a:txBody>
+                  <a:tcPr marL="91440" marR="91440" marT="45720" marB="45720" anchor="ctr">
+                    <a:lnL w="9525" cap="flat" cmpd="sng" algn="ctr">
+                      <a:solidFill>
+                        <a:srgbClr val="C9D6D2"/>
+                      </a:solidFill>
+                      <a:prstDash val="solid"/>
+                      <a:round/>
+                      <a:headEnd type="none" w="med" len="med"/>
+                      <a:tailEnd type="none" w="med" len="med"/>
+                    </a:lnL>
+                    <a:lnR w="9525" cap="flat" cmpd="sng" algn="ctr">
+                      <a:solidFill>
+                        <a:srgbClr val="C9D6D2"/>
+                      </a:solidFill>
+                      <a:prstDash val="solid"/>
+                      <a:round/>
+                      <a:headEnd type="none" w="med" len="med"/>
+                      <a:tailEnd type="none" w="med" len="med"/>
+                    </a:lnR>
+                    <a:lnT w="9525" cap="flat" cmpd="sng" algn="ctr">
+                      <a:solidFill>
+                        <a:srgbClr val="C9D6D2"/>
+                      </a:solidFill>
+                      <a:prstDash val="solid"/>
+                      <a:round/>
+                      <a:headEnd type="none" w="med" len="med"/>
+                      <a:tailEnd type="none" w="med" len="med"/>
+                    </a:lnT>
+                    <a:lnB w="9525" cap="flat" cmpd="sng" algn="ctr">
+                      <a:solidFill>
+                        <a:srgbClr val="C9D6D2"/>
+                      </a:solidFill>
+                      <a:prstDash val="solid"/>
+                      <a:round/>
+                      <a:headEnd type="none" w="med" len="med"/>
+                      <a:tailEnd type="none" w="med" len="med"/>
+                    </a:lnB>
+                    <a:solidFill>
+                      <a:schemeClr val="bg1"/>
+                    </a:solidFill>
+                  </a:tcPr>
+                </a:tc>
               </a:tr>
               <a:tr h="548640">
                 <a:tc>
@@ -4206,6 +4512,59 @@
                         </a:rPr>
                         <a:t>+25.3</a:t>
                       </a:r>
+                      <a:endParaRPr lang="en-US" sz="1600" dirty="0"/>
+                    </a:p>
+                  </a:txBody>
+                  <a:tcPr marL="91440" marR="91440" marT="45720" marB="45720" anchor="ctr">
+                    <a:lnL w="9525" cap="flat" cmpd="sng" algn="ctr">
+                      <a:solidFill>
+                        <a:srgbClr val="C9D6D2"/>
+                      </a:solidFill>
+                      <a:prstDash val="solid"/>
+                      <a:round/>
+                      <a:headEnd type="none" w="med" len="med"/>
+                      <a:tailEnd type="none" w="med" len="med"/>
+                    </a:lnL>
+                    <a:lnR w="9525" cap="flat" cmpd="sng" algn="ctr">
+                      <a:solidFill>
+                        <a:srgbClr val="C9D6D2"/>
+                      </a:solidFill>
+                      <a:prstDash val="solid"/>
+                      <a:round/>
+                      <a:headEnd type="none" w="med" len="med"/>
+                      <a:tailEnd type="none" w="med" len="med"/>
+                    </a:lnR>
+                    <a:lnT w="9525" cap="flat" cmpd="sng" algn="ctr">
+                      <a:solidFill>
+                        <a:srgbClr val="C9D6D2"/>
+                      </a:solidFill>
+                      <a:prstDash val="solid"/>
+                      <a:round/>
+                      <a:headEnd type="none" w="med" len="med"/>
+                      <a:tailEnd type="none" w="med" len="med"/>
+                    </a:lnT>
+                    <a:lnB w="9525" cap="flat" cmpd="sng" algn="ctr">
+                      <a:solidFill>
+                        <a:srgbClr val="C9D6D2"/>
+                      </a:solidFill>
+                      <a:prstDash val="solid"/>
+                      <a:round/>
+                      <a:headEnd type="none" w="med" len="med"/>
+                      <a:tailEnd type="none" w="med" len="med"/>
+                    </a:lnB>
+                    <a:solidFill>
+                      <a:schemeClr val="bg2"/>
+                    </a:solidFill>
+                  </a:tcPr>
+                </a:tc>
+                <a:tc>
+                  <a:txBody>
+                    <a:bodyPr/>
+                    <a:lstStyle/>
+                    <a:p>
+                      <a:pPr algn="ctr" indent="0" marL="0">
+                        <a:buNone/>
+                      </a:pPr>
                       <a:endParaRPr lang="en-US" sz="1600" dirty="0"/>
                     </a:p>
                   </a:txBody>

</xml_diff>